<commit_message>
Restrict the nucleation chain to monodentate binding
The Venables slide was feeding TPBi and the inorganic clusters through an
E_d = 0.28 E_b correlation that assumes a single-site contact.  With a
different coordination number the escape barrier and the site density stop
being the same quantity, so a bidentate chelate cannot go in that chain.

It now compares monodentate organics only, and labels each with its site count
per molecule, which is the term the ranking actually turns on: HATCN carries
six, F4TCNQ four, B3PyMPM two.
</commit_message>
<xml_diff>
--- a/dft_seedlayer_screen/ppt/Ag_electrode_summary.pptx
+++ b/dft_seedlayer_screen/ppt/Ag_electrode_summary.pptx
@@ -1515,7 +1515,7 @@
             <c:bubble3D val="0"/>
             <c:spPr>
               <a:solidFill>
-                <a:srgbClr val="FF6B35"/>
+                <a:srgbClr val="9AA5BC"/>
               </a:solidFill>
               <a:effectLst/>
             </c:spPr>
@@ -1526,7 +1526,7 @@
             <c:bubble3D val="0"/>
             <c:spPr>
               <a:solidFill>
-                <a:srgbClr val="C0392B"/>
+                <a:srgbClr val="C5CEDE"/>
               </a:solidFill>
               <a:effectLst/>
             </c:spPr>
@@ -1537,7 +1537,7 @@
             <c:bubble3D val="0"/>
             <c:spPr>
               <a:solidFill>
-                <a:srgbClr val="C0392B"/>
+                <a:srgbClr val="C5CEDE"/>
               </a:solidFill>
               <a:effectLst/>
             </c:spPr>
@@ -1549,22 +1549,22 @@
                 <c:ptCount val="6"/>
                 <c:lvl>
                   <c:pt idx="0">
-                    <c:v>HATCN</c:v>
+                    <c:v>HATCN  (6자리)</c:v>
                   </c:pt>
                   <c:pt idx="1">
-                    <c:v>F4TCNQ</c:v>
+                    <c:v>F4TCNQ  (4자리)</c:v>
                   </c:pt>
                   <c:pt idx="2">
-                    <c:v>TPBi</c:v>
+                    <c:v>B3PyMPM  (2자리)</c:v>
                   </c:pt>
                   <c:pt idx="3">
-                    <c:v>MoOx</c:v>
+                    <c:v>pyridine  (1자리)</c:v>
                   </c:pt>
                   <c:pt idx="4">
-                    <c:v>MoO3</c:v>
+                    <c:v>triazine  (3자리)</c:v>
                   </c:pt>
                   <c:pt idx="5">
-                    <c:v>LiF</c:v>
+                    <c:v>BTD  (1자리)</c:v>
                   </c:pt>
                 </c:lvl>
               </c:multiLvlStrCache>
@@ -1583,10 +1583,10 @@
                   <c:v>0.4123</c:v>
                 </c:pt>
                 <c:pt idx="2">
-                  <c:v>0.1396</c:v>
+                  <c:v>0.0035</c:v>
                 </c:pt>
                 <c:pt idx="3">
-                  <c:v>0.0003</c:v>
+                  <c:v>0.0001</c:v>
                 </c:pt>
                 <c:pt idx="4">
                   <c:v>0.00005</c:v>
@@ -21171,7 +21171,7 @@
         <p:spPr>
           <a:xfrm>
             <a:off x="566928" y="3611880"/>
-            <a:ext cx="5486400" cy="320040"/>
+            <a:ext cx="5852160" cy="320040"/>
           </a:xfrm>
           <a:prstGeom prst="rect">
             <a:avLst/>
@@ -21195,7 +21195,7 @@
                 <a:ea typeface="Malgun Gothic" pitchFamily="34" charset="-122"/>
                 <a:cs typeface="Malgun Gothic" pitchFamily="34" charset="-120"/>
               </a:rPr>
-              <a:t>Venables 포화 핵밀도 — HATCN 기준 1.0</a:t>
+              <a:t>Venables 포화 핵밀도 — 단좌 결합끼리만 비교, HATCN 기준 1.0</a:t>
             </a:r>
             <a:endParaRPr lang="en-US" sz="1300" dirty="0"/>
           </a:p>
@@ -21315,7 +21315,7 @@
                 <a:ea typeface="Malgun Gothic" pitchFamily="34" charset="-122"/>
                 <a:cs typeface="Malgun Gothic" pitchFamily="34" charset="-120"/>
               </a:rPr>
-              <a:t>Venables 는 HATCN/MoOx 핵밀도 비를 3300배로 준다</a:t>
+              <a:t>E_d = 0.28·E_b 상관식은 단좌 전제 — 이좌 킬레이트(TPBi, Bphen)와 무기물은 이 사슬에 넣을 수 없다</a:t>
             </a:r>
             <a:endParaRPr lang="en-US" sz="1050" dirty="0"/>
           </a:p>
@@ -21336,7 +21336,7 @@
                 <a:ea typeface="Malgun Gothic" pitchFamily="34" charset="-122"/>
                 <a:cs typeface="Malgun Gothic" pitchFamily="34" charset="-120"/>
               </a:rPr>
-              <a:t>그대로면 닫힘 두께가 수십 배 차이나야 하지만 실측은 5 vs 7 nm</a:t>
+              <a:t>단좌끼리 비교해도 HATCN/MoOx 비가 3300배 — 그대로면 닫힘 두께가 수십 배 차이나야 하지만 실측은 5 vs 7 nm</a:t>
             </a:r>
             <a:endParaRPr lang="en-US" sz="1050" dirty="0"/>
           </a:p>

</xml_diff>